<commit_message>
final commit: completed thesis
</commit_message>
<xml_diff>
--- a/tex/pptx/thesis/output/thesis_presentation.pptx
+++ b/tex/pptx/thesis/output/thesis_presentation.pptx
@@ -145,7 +145,7 @@
       </p:grpSpPr>
       <p:sp>
         <p:nvSpPr>
-          <p:cNvPr id="1001072657" name="Header Placeholder 1"/>
+          <p:cNvPr id="1303007942" name="Header Placeholder 1"/>
           <p:cNvSpPr>
             <a:spLocks noGrp="1"/>
           </p:cNvSpPr>
@@ -179,7 +179,7 @@
       </p:sp>
       <p:sp>
         <p:nvSpPr>
-          <p:cNvPr id="846176761" name="Date Placeholder 2"/>
+          <p:cNvPr id="906787102" name="Date Placeholder 2"/>
           <p:cNvSpPr>
             <a:spLocks noGrp="1"/>
           </p:cNvSpPr>
@@ -213,7 +213,7 @@
       </p:sp>
       <p:sp>
         <p:nvSpPr>
-          <p:cNvPr id="1681893293" name="Date Placeholder 2"/>
+          <p:cNvPr id="900038853" name="Date Placeholder 2"/>
           <p:cNvSpPr>
             <a:spLocks noGrp="1"/>
           </p:cNvSpPr>
@@ -247,7 +247,7 @@
       </p:sp>
       <p:sp>
         <p:nvSpPr>
-          <p:cNvPr id="539822802" name="Notes Placeholder 4"/>
+          <p:cNvPr id="236003537" name="Notes Placeholder 4"/>
           <p:cNvSpPr>
             <a:spLocks noGrp="1"/>
           </p:cNvSpPr>
@@ -277,7 +277,7 @@
       </p:sp>
       <p:sp>
         <p:nvSpPr>
-          <p:cNvPr id="2089703935" name="Footer Placeholder 5"/>
+          <p:cNvPr id="1620166048" name="Footer Placeholder 5"/>
           <p:cNvSpPr>
             <a:spLocks noGrp="1"/>
           </p:cNvSpPr>
@@ -311,7 +311,7 @@
       </p:sp>
       <p:sp>
         <p:nvSpPr>
-          <p:cNvPr id="1593968712" name="Slide Number Placeholder 6"/>
+          <p:cNvPr id="1276571672" name="Slide Number Placeholder 6"/>
           <p:cNvSpPr>
             <a:spLocks noGrp="1"/>
           </p:cNvSpPr>
@@ -460,7 +460,7 @@
       </p:grpSpPr>
       <p:sp>
         <p:nvSpPr>
-          <p:cNvPr id="602288130" name="Slide Image Placeholder 1"/>
+          <p:cNvPr id="1055490363" name="Slide Image Placeholder 1"/>
           <p:cNvSpPr>
             <a:spLocks noChangeAspect="1" noGrp="1" noRot="1"/>
           </p:cNvSpPr>
@@ -472,7 +472,7 @@
       </p:sp>
       <p:sp>
         <p:nvSpPr>
-          <p:cNvPr id="1123915048" name="Notes Placeholder 2"/>
+          <p:cNvPr id="862433098" name="Notes Placeholder 2"/>
           <p:cNvSpPr>
             <a:spLocks noGrp="1"/>
           </p:cNvSpPr>
@@ -488,13 +488,24 @@
             <a:pPr>
               <a:defRPr/>
             </a:pPr>
-            <a:endParaRPr/>
-          </a:p>
-        </p:txBody>
-      </p:sp>
-      <p:sp>
-        <p:nvSpPr>
-          <p:cNvPr id="1809903380" name="Slide Number Placeholder 3"/>
+            <a:r>
+              <a:rPr sz="1050" b="0" i="0" u="none">
+                <a:solidFill>
+                  <a:srgbClr val="FFFFFF"/>
+                </a:solidFill>
+                <a:latin typeface="Droid Sans Mono"/>
+                <a:ea typeface="Droid Sans Mono"/>
+                <a:cs typeface="Droid Sans Mono"/>
+              </a:rPr>
+              <a:t>  Welcome. My thesis is about RAG Poison Lab, a controlled benchmark for studying poisoning risks in LLM-powered recommendation systems. The key idea is simple: recommendation pipelines increasingly retrieve text metadata before ranking or reranking. If that retrieved text is manipulated, the final recommendation can change even when the model itself is not retrained. Today I will focus on the engineering benchmark, the experiment loop, and the main security interpretation.</a:t>
+            </a:r>
+            <a:endParaRPr/>
+          </a:p>
+        </p:txBody>
+      </p:sp>
+      <p:sp>
+        <p:nvSpPr>
+          <p:cNvPr id="1815757108" name="Slide Number Placeholder 3"/>
           <p:cNvSpPr>
             <a:spLocks noGrp="1"/>
           </p:cNvSpPr>
@@ -545,7 +556,7 @@
       </p:grpSpPr>
       <p:sp>
         <p:nvSpPr>
-          <p:cNvPr id="1235468099" name="Slide Image Placeholder 1"/>
+          <p:cNvPr id="2087402749" name="Slide Image Placeholder 1"/>
           <p:cNvSpPr>
             <a:spLocks noChangeAspect="1" noGrp="1" noRot="1"/>
           </p:cNvSpPr>
@@ -557,7 +568,7 @@
       </p:sp>
       <p:sp>
         <p:nvSpPr>
-          <p:cNvPr id="2131454640" name="Notes Placeholder 2"/>
+          <p:cNvPr id="1507856037" name="Notes Placeholder 2"/>
           <p:cNvSpPr>
             <a:spLocks noGrp="1"/>
           </p:cNvSpPr>
@@ -579,7 +590,7 @@
       </p:sp>
       <p:sp>
         <p:nvSpPr>
-          <p:cNvPr id="1902433176" name="Slide Number Placeholder 3"/>
+          <p:cNvPr id="1721215378" name="Slide Number Placeholder 3"/>
           <p:cNvSpPr>
             <a:spLocks noGrp="1"/>
           </p:cNvSpPr>
@@ -630,7 +641,7 @@
       </p:grpSpPr>
       <p:sp>
         <p:nvSpPr>
-          <p:cNvPr id="1132499435" name="Slide Image Placeholder 1"/>
+          <p:cNvPr id="1835973732" name="Slide Image Placeholder 1"/>
           <p:cNvSpPr>
             <a:spLocks noChangeAspect="1" noGrp="1" noRot="1"/>
           </p:cNvSpPr>
@@ -642,7 +653,7 @@
       </p:sp>
       <p:sp>
         <p:nvSpPr>
-          <p:cNvPr id="430064709" name="Notes Placeholder 2"/>
+          <p:cNvPr id="523377682" name="Notes Placeholder 2"/>
           <p:cNvSpPr>
             <a:spLocks noGrp="1"/>
           </p:cNvSpPr>
@@ -664,7 +675,7 @@
       </p:sp>
       <p:sp>
         <p:nvSpPr>
-          <p:cNvPr id="2042767513" name="Slide Number Placeholder 3"/>
+          <p:cNvPr id="486813162" name="Slide Number Placeholder 3"/>
           <p:cNvSpPr>
             <a:spLocks noGrp="1"/>
           </p:cNvSpPr>
@@ -715,7 +726,7 @@
       </p:grpSpPr>
       <p:sp>
         <p:nvSpPr>
-          <p:cNvPr id="626096012" name="Slide Image Placeholder 1"/>
+          <p:cNvPr id="908046750" name="Slide Image Placeholder 1"/>
           <p:cNvSpPr>
             <a:spLocks noChangeAspect="1" noGrp="1" noRot="1"/>
           </p:cNvSpPr>
@@ -727,7 +738,7 @@
       </p:sp>
       <p:sp>
         <p:nvSpPr>
-          <p:cNvPr id="1073625522" name="Notes Placeholder 2"/>
+          <p:cNvPr id="1504850010" name="Notes Placeholder 2"/>
           <p:cNvSpPr>
             <a:spLocks noGrp="1"/>
           </p:cNvSpPr>
@@ -749,7 +760,7 @@
       </p:sp>
       <p:sp>
         <p:nvSpPr>
-          <p:cNvPr id="570380457" name="Slide Number Placeholder 3"/>
+          <p:cNvPr id="815278265" name="Slide Number Placeholder 3"/>
           <p:cNvSpPr>
             <a:spLocks noGrp="1"/>
           </p:cNvSpPr>
@@ -800,7 +811,7 @@
       </p:grpSpPr>
       <p:sp>
         <p:nvSpPr>
-          <p:cNvPr id="1015004951" name="Slide Image Placeholder 1"/>
+          <p:cNvPr id="1827571453" name="Slide Image Placeholder 1"/>
           <p:cNvSpPr>
             <a:spLocks noChangeAspect="1" noGrp="1" noRot="1"/>
           </p:cNvSpPr>
@@ -812,7 +823,7 @@
       </p:sp>
       <p:sp>
         <p:nvSpPr>
-          <p:cNvPr id="235234984" name="Notes Placeholder 2"/>
+          <p:cNvPr id="36547807" name="Notes Placeholder 2"/>
           <p:cNvSpPr>
             <a:spLocks noGrp="1"/>
           </p:cNvSpPr>
@@ -828,13 +839,24 @@
             <a:pPr>
               <a:defRPr/>
             </a:pPr>
-            <a:endParaRPr/>
-          </a:p>
-        </p:txBody>
-      </p:sp>
-      <p:sp>
-        <p:nvSpPr>
-          <p:cNvPr id="1066946344" name="Slide Number Placeholder 3"/>
+            <a:r>
+              <a:rPr sz="1050" b="0" i="0" u="none">
+                <a:solidFill>
+                  <a:srgbClr val="FFFFFF"/>
+                </a:solidFill>
+                <a:latin typeface="Droid Sans Mono"/>
+                <a:ea typeface="Droid Sans Mono"/>
+                <a:cs typeface="Droid Sans Mono"/>
+              </a:rPr>
+              <a:t>n a RAG-style recommender, the retrieved movie record is not passive storage anymore. It becomes evidence for ranking, reranking, or explanation. That means the attack surface moves earlier in the pipeline, into the indexed metadata. The thesis studies this boundary: a clean index and a poisoned index are evaluated under the same user and metric conditions, so the difference is attributable to the retrieval condition rather than to a new model or a different user sample.</a:t>
+            </a:r>
+            <a:endParaRPr/>
+          </a:p>
+        </p:txBody>
+      </p:sp>
+      <p:sp>
+        <p:nvSpPr>
+          <p:cNvPr id="1772869597" name="Slide Number Placeholder 3"/>
           <p:cNvSpPr>
             <a:spLocks noGrp="1"/>
           </p:cNvSpPr>
@@ -885,7 +907,7 @@
       </p:grpSpPr>
       <p:sp>
         <p:nvSpPr>
-          <p:cNvPr id="1233145556" name="Slide Image Placeholder 1"/>
+          <p:cNvPr id="1437370559" name="Slide Image Placeholder 1"/>
           <p:cNvSpPr>
             <a:spLocks noChangeAspect="1" noGrp="1" noRot="1"/>
           </p:cNvSpPr>
@@ -897,7 +919,7 @@
       </p:sp>
       <p:sp>
         <p:nvSpPr>
-          <p:cNvPr id="1889132172" name="Notes Placeholder 2"/>
+          <p:cNvPr id="1041640596" name="Notes Placeholder 2"/>
           <p:cNvSpPr>
             <a:spLocks noGrp="1"/>
           </p:cNvSpPr>
@@ -913,13 +935,24 @@
             <a:pPr>
               <a:defRPr/>
             </a:pPr>
-            <a:endParaRPr/>
-          </a:p>
-        </p:txBody>
-      </p:sp>
-      <p:sp>
-        <p:nvSpPr>
-          <p:cNvPr id="1549812070" name="Slide Number Placeholder 3"/>
+            <a:r>
+              <a:rPr sz="1050" b="0" i="0" u="none">
+                <a:solidFill>
+                  <a:srgbClr val="FFFFFF"/>
+                </a:solidFill>
+                <a:latin typeface="Droid Sans Mono"/>
+                <a:ea typeface="Droid Sans Mono"/>
+                <a:cs typeface="Droid Sans Mono"/>
+              </a:rPr>
+              <a:t>The central question is how to compare clean and poisoned retrieval conditions while keeping the experiment auditable. The project contributes three things. First, a controlled local benchmark with clean and poisoned indices. Second, three attack families that represent different failure modes rather than one isolated trick. Third, a reproducible evidence trail: metrics, runtime configuration, traces, and a final experiment matrix. I am intentionally not claiming that this proves every recommender is unsafe; it is a local benchmark for studying behavior.</a:t>
+            </a:r>
+            <a:endParaRPr/>
+          </a:p>
+        </p:txBody>
+      </p:sp>
+      <p:sp>
+        <p:nvSpPr>
+          <p:cNvPr id="1404797572" name="Slide Number Placeholder 3"/>
           <p:cNvSpPr>
             <a:spLocks noGrp="1"/>
           </p:cNvSpPr>
@@ -970,7 +1003,7 @@
       </p:grpSpPr>
       <p:sp>
         <p:nvSpPr>
-          <p:cNvPr id="1369443679" name="Slide Image Placeholder 1"/>
+          <p:cNvPr id="477766067" name="Slide Image Placeholder 1"/>
           <p:cNvSpPr>
             <a:spLocks noChangeAspect="1" noGrp="1" noRot="1"/>
           </p:cNvSpPr>
@@ -982,7 +1015,7 @@
       </p:sp>
       <p:sp>
         <p:nvSpPr>
-          <p:cNvPr id="988600214" name="Notes Placeholder 2"/>
+          <p:cNvPr id="958944020" name="Notes Placeholder 2"/>
           <p:cNvSpPr>
             <a:spLocks noGrp="1"/>
           </p:cNvSpPr>
@@ -998,13 +1031,24 @@
             <a:pPr>
               <a:defRPr/>
             </a:pPr>
-            <a:endParaRPr/>
-          </a:p>
-        </p:txBody>
-      </p:sp>
-      <p:sp>
-        <p:nvSpPr>
-          <p:cNvPr id="1425264794" name="Slide Number Placeholder 3"/>
+            <a:r>
+              <a:rPr sz="1050" b="0" i="0" u="none">
+                <a:solidFill>
+                  <a:srgbClr val="FFFFFF"/>
+                </a:solidFill>
+                <a:latin typeface="Droid Sans Mono"/>
+                <a:ea typeface="Droid Sans Mono"/>
+                <a:cs typeface="Droid Sans Mono"/>
+              </a:rPr>
+              <a:t>The thesis builds on three nearby threads. Retrieval poisoning shows that modified passages or records can change what a downstream system sees. Indirect prompt injection explains why external content can become instruction-like once it reaches an LLM context. RAG poisoning in recommender systems connects those ideas to exposure and ranking.</a:t>
+            </a:r>
+            <a:endParaRPr/>
+          </a:p>
+        </p:txBody>
+      </p:sp>
+      <p:sp>
+        <p:nvSpPr>
+          <p:cNvPr id="500613809" name="Slide Number Placeholder 3"/>
           <p:cNvSpPr>
             <a:spLocks noGrp="1"/>
           </p:cNvSpPr>
@@ -1055,7 +1099,7 @@
       </p:grpSpPr>
       <p:sp>
         <p:nvSpPr>
-          <p:cNvPr id="978435175" name="Slide Image Placeholder 1"/>
+          <p:cNvPr id="1239807712" name="Slide Image Placeholder 1"/>
           <p:cNvSpPr>
             <a:spLocks noChangeAspect="1" noGrp="1" noRot="1"/>
           </p:cNvSpPr>
@@ -1067,7 +1111,7 @@
       </p:sp>
       <p:sp>
         <p:nvSpPr>
-          <p:cNvPr id="1822362712" name="Notes Placeholder 2"/>
+          <p:cNvPr id="105311844" name="Notes Placeholder 2"/>
           <p:cNvSpPr>
             <a:spLocks noGrp="1"/>
           </p:cNvSpPr>
@@ -1083,13 +1127,24 @@
             <a:pPr>
               <a:defRPr/>
             </a:pPr>
-            <a:endParaRPr/>
-          </a:p>
-        </p:txBody>
-      </p:sp>
-      <p:sp>
-        <p:nvSpPr>
-          <p:cNvPr id="68640586" name="Slide Number Placeholder 3"/>
+            <a:r>
+              <a:rPr sz="1050" b="0" i="0" u="none">
+                <a:solidFill>
+                  <a:srgbClr val="FFFFFF"/>
+                </a:solidFill>
+                <a:latin typeface="Droid Sans Mono"/>
+                <a:ea typeface="Droid Sans Mono"/>
+                <a:cs typeface="Droid Sans Mono"/>
+              </a:rPr>
+              <a:t>This slide is reserved for the architecture diagram. The system is built around a FastAPI backend, Elasticsearch retrieval, a poisoning builder, an evaluation runner, and a React frontend. The important defense point is separation: data preparation, poisoning, indexing, recommendation, and reporting are distinct stages. That lets the project preserve evidence about what changed and where it changed, instead of reducing the experiment to a single opaque model response.</a:t>
+            </a:r>
+            <a:endParaRPr/>
+          </a:p>
+        </p:txBody>
+      </p:sp>
+      <p:sp>
+        <p:nvSpPr>
+          <p:cNvPr id="140073633" name="Slide Number Placeholder 3"/>
           <p:cNvSpPr>
             <a:spLocks noGrp="1"/>
           </p:cNvSpPr>
@@ -1140,7 +1195,7 @@
       </p:grpSpPr>
       <p:sp>
         <p:nvSpPr>
-          <p:cNvPr id="1996966747" name="Slide Image Placeholder 1"/>
+          <p:cNvPr id="1671640872" name="Slide Image Placeholder 1"/>
           <p:cNvSpPr>
             <a:spLocks noChangeAspect="1" noGrp="1" noRot="1"/>
           </p:cNvSpPr>
@@ -1152,7 +1207,7 @@
       </p:sp>
       <p:sp>
         <p:nvSpPr>
-          <p:cNvPr id="1867445806" name="Notes Placeholder 2"/>
+          <p:cNvPr id="1785378069" name="Notes Placeholder 2"/>
           <p:cNvSpPr>
             <a:spLocks noGrp="1"/>
           </p:cNvSpPr>
@@ -1174,7 +1229,7 @@
       </p:sp>
       <p:sp>
         <p:nvSpPr>
-          <p:cNvPr id="1456973588" name="Slide Number Placeholder 3"/>
+          <p:cNvPr id="602592727" name="Slide Number Placeholder 3"/>
           <p:cNvSpPr>
             <a:spLocks noGrp="1"/>
           </p:cNvSpPr>
@@ -1225,7 +1280,7 @@
       </p:grpSpPr>
       <p:sp>
         <p:nvSpPr>
-          <p:cNvPr id="632485405" name="Slide Image Placeholder 1"/>
+          <p:cNvPr id="110024413" name="Slide Image Placeholder 1"/>
           <p:cNvSpPr>
             <a:spLocks noChangeAspect="1" noGrp="1" noRot="1"/>
           </p:cNvSpPr>
@@ -1237,7 +1292,7 @@
       </p:sp>
       <p:sp>
         <p:nvSpPr>
-          <p:cNvPr id="1962025099" name="Notes Placeholder 2"/>
+          <p:cNvPr id="1360014393" name="Notes Placeholder 2"/>
           <p:cNvSpPr>
             <a:spLocks noGrp="1"/>
           </p:cNvSpPr>
@@ -1259,7 +1314,7 @@
       </p:sp>
       <p:sp>
         <p:nvSpPr>
-          <p:cNvPr id="1062045546" name="Slide Number Placeholder 3"/>
+          <p:cNvPr id="491511222" name="Slide Number Placeholder 3"/>
           <p:cNvSpPr>
             <a:spLocks noGrp="1"/>
           </p:cNvSpPr>
@@ -1310,7 +1365,7 @@
       </p:grpSpPr>
       <p:sp>
         <p:nvSpPr>
-          <p:cNvPr id="420242484" name="Slide Image Placeholder 1"/>
+          <p:cNvPr id="2092647112" name="Slide Image Placeholder 1"/>
           <p:cNvSpPr>
             <a:spLocks noChangeAspect="1" noGrp="1" noRot="1"/>
           </p:cNvSpPr>
@@ -1322,7 +1377,7 @@
       </p:sp>
       <p:sp>
         <p:nvSpPr>
-          <p:cNvPr id="1623470415" name="Notes Placeholder 2"/>
+          <p:cNvPr id="1815095837" name="Notes Placeholder 2"/>
           <p:cNvSpPr>
             <a:spLocks noGrp="1"/>
           </p:cNvSpPr>
@@ -1344,7 +1399,7 @@
       </p:sp>
       <p:sp>
         <p:nvSpPr>
-          <p:cNvPr id="1353017125" name="Slide Number Placeholder 3"/>
+          <p:cNvPr id="183699025" name="Slide Number Placeholder 3"/>
           <p:cNvSpPr>
             <a:spLocks noGrp="1"/>
           </p:cNvSpPr>
@@ -1395,7 +1450,7 @@
       </p:grpSpPr>
       <p:sp>
         <p:nvSpPr>
-          <p:cNvPr id="1241901838" name="Slide Image Placeholder 1"/>
+          <p:cNvPr id="953491062" name="Slide Image Placeholder 1"/>
           <p:cNvSpPr>
             <a:spLocks noChangeAspect="1" noGrp="1" noRot="1"/>
           </p:cNvSpPr>
@@ -1407,7 +1462,7 @@
       </p:sp>
       <p:sp>
         <p:nvSpPr>
-          <p:cNvPr id="728814858" name="Notes Placeholder 2"/>
+          <p:cNvPr id="2038651183" name="Notes Placeholder 2"/>
           <p:cNvSpPr>
             <a:spLocks noGrp="1"/>
           </p:cNvSpPr>
@@ -1429,7 +1484,7 @@
       </p:sp>
       <p:sp>
         <p:nvSpPr>
-          <p:cNvPr id="2131650878" name="Slide Number Placeholder 3"/>
+          <p:cNvPr id="41393481" name="Slide Number Placeholder 3"/>
           <p:cNvSpPr>
             <a:spLocks noGrp="1"/>
           </p:cNvSpPr>
@@ -1480,7 +1535,7 @@
       </p:grpSpPr>
       <p:sp>
         <p:nvSpPr>
-          <p:cNvPr id="1268772224" name="Title 1"/>
+          <p:cNvPr id="726265117" name="Title 1"/>
           <p:cNvSpPr>
             <a:spLocks noGrp="1"/>
           </p:cNvSpPr>
@@ -1511,7 +1566,7 @@
       </p:sp>
       <p:sp>
         <p:nvSpPr>
-          <p:cNvPr id="1996863739" name="Subtitle 2"/>
+          <p:cNvPr id="256387204" name="Subtitle 2"/>
           <p:cNvSpPr>
             <a:spLocks noGrp="1"/>
           </p:cNvSpPr>
@@ -1633,7 +1688,7 @@
       </p:sp>
       <p:sp>
         <p:nvSpPr>
-          <p:cNvPr id="1703656673" name="Date Placeholder 3"/>
+          <p:cNvPr id="2064998434" name="Date Placeholder 3"/>
           <p:cNvSpPr>
             <a:spLocks noGrp="1"/>
           </p:cNvSpPr>
@@ -1659,7 +1714,7 @@
       </p:sp>
       <p:sp>
         <p:nvSpPr>
-          <p:cNvPr id="672881696" name="Footer Placeholder 4"/>
+          <p:cNvPr id="1151214031" name="Footer Placeholder 4"/>
           <p:cNvSpPr>
             <a:spLocks noGrp="1"/>
           </p:cNvSpPr>
@@ -1681,7 +1736,7 @@
       </p:sp>
       <p:sp>
         <p:nvSpPr>
-          <p:cNvPr id="1689840276" name="Slide Number Placeholder 5"/>
+          <p:cNvPr id="2109798171" name="Slide Number Placeholder 5"/>
           <p:cNvSpPr>
             <a:spLocks noGrp="1"/>
           </p:cNvSpPr>
@@ -1732,7 +1787,7 @@
       </p:grpSpPr>
       <p:sp>
         <p:nvSpPr>
-          <p:cNvPr id="1623079293" name="Title 1"/>
+          <p:cNvPr id="905961152" name="Title 1"/>
           <p:cNvSpPr>
             <a:spLocks noGrp="1"/>
           </p:cNvSpPr>
@@ -1758,7 +1813,7 @@
       </p:sp>
       <p:sp>
         <p:nvSpPr>
-          <p:cNvPr id="210930016" name="Vertical Text Placeholder 2"/>
+          <p:cNvPr id="31596016" name="Vertical Text Placeholder 2"/>
           <p:cNvSpPr>
             <a:spLocks noGrp="1"/>
           </p:cNvSpPr>
@@ -1824,7 +1879,7 @@
       </p:sp>
       <p:sp>
         <p:nvSpPr>
-          <p:cNvPr id="1723203712" name="Date Placeholder 3"/>
+          <p:cNvPr id="1291431447" name="Date Placeholder 3"/>
           <p:cNvSpPr>
             <a:spLocks noGrp="1"/>
           </p:cNvSpPr>
@@ -1850,7 +1905,7 @@
       </p:sp>
       <p:sp>
         <p:nvSpPr>
-          <p:cNvPr id="658748214" name="Footer Placeholder 4"/>
+          <p:cNvPr id="1917020657" name="Footer Placeholder 4"/>
           <p:cNvSpPr>
             <a:spLocks noGrp="1"/>
           </p:cNvSpPr>
@@ -1872,7 +1927,7 @@
       </p:sp>
       <p:sp>
         <p:nvSpPr>
-          <p:cNvPr id="2077781792" name="Slide Number Placeholder 5"/>
+          <p:cNvPr id="704972561" name="Slide Number Placeholder 5"/>
           <p:cNvSpPr>
             <a:spLocks noGrp="1"/>
           </p:cNvSpPr>
@@ -1923,7 +1978,7 @@
       </p:grpSpPr>
       <p:sp>
         <p:nvSpPr>
-          <p:cNvPr id="1619276550" name="Vertical Title 1"/>
+          <p:cNvPr id="396603140" name="Vertical Title 1"/>
           <p:cNvSpPr>
             <a:spLocks noGrp="1"/>
           </p:cNvSpPr>
@@ -1954,7 +2009,7 @@
       </p:sp>
       <p:sp>
         <p:nvSpPr>
-          <p:cNvPr id="808414068" name="Vertical Text Placeholder 2"/>
+          <p:cNvPr id="1632692228" name="Vertical Text Placeholder 2"/>
           <p:cNvSpPr>
             <a:spLocks noGrp="1"/>
           </p:cNvSpPr>
@@ -2025,7 +2080,7 @@
       </p:sp>
       <p:sp>
         <p:nvSpPr>
-          <p:cNvPr id="783356584" name="Date Placeholder 3"/>
+          <p:cNvPr id="1634968764" name="Date Placeholder 3"/>
           <p:cNvSpPr>
             <a:spLocks noGrp="1"/>
           </p:cNvSpPr>
@@ -2051,7 +2106,7 @@
       </p:sp>
       <p:sp>
         <p:nvSpPr>
-          <p:cNvPr id="701561171" name="Footer Placeholder 4"/>
+          <p:cNvPr id="410775237" name="Footer Placeholder 4"/>
           <p:cNvSpPr>
             <a:spLocks noGrp="1"/>
           </p:cNvSpPr>
@@ -2073,7 +2128,7 @@
       </p:sp>
       <p:sp>
         <p:nvSpPr>
-          <p:cNvPr id="1459147461" name="Slide Number Placeholder 5"/>
+          <p:cNvPr id="352825025" name="Slide Number Placeholder 5"/>
           <p:cNvSpPr>
             <a:spLocks noGrp="1"/>
           </p:cNvSpPr>
@@ -2124,7 +2179,7 @@
       </p:grpSpPr>
       <p:sp>
         <p:nvSpPr>
-          <p:cNvPr id="537840528" name="Title 1"/>
+          <p:cNvPr id="1224397910" name="Title 1"/>
           <p:cNvSpPr>
             <a:spLocks noGrp="1"/>
           </p:cNvSpPr>
@@ -2150,7 +2205,7 @@
       </p:sp>
       <p:sp>
         <p:nvSpPr>
-          <p:cNvPr id="546573187" name="Content Placeholder 2"/>
+          <p:cNvPr id="683377393" name="Content Placeholder 2"/>
           <p:cNvSpPr>
             <a:spLocks noGrp="1"/>
           </p:cNvSpPr>
@@ -2216,7 +2271,7 @@
       </p:sp>
       <p:sp>
         <p:nvSpPr>
-          <p:cNvPr id="182487058" name="Date Placeholder 3"/>
+          <p:cNvPr id="144043909" name="Date Placeholder 3"/>
           <p:cNvSpPr>
             <a:spLocks noGrp="1"/>
           </p:cNvSpPr>
@@ -2242,7 +2297,7 @@
       </p:sp>
       <p:sp>
         <p:nvSpPr>
-          <p:cNvPr id="1091436631" name="Footer Placeholder 4"/>
+          <p:cNvPr id="2021677060" name="Footer Placeholder 4"/>
           <p:cNvSpPr>
             <a:spLocks noGrp="1"/>
           </p:cNvSpPr>
@@ -2264,7 +2319,7 @@
       </p:sp>
       <p:sp>
         <p:nvSpPr>
-          <p:cNvPr id="1810571842" name="Slide Number Placeholder 5"/>
+          <p:cNvPr id="1104951770" name="Slide Number Placeholder 5"/>
           <p:cNvSpPr>
             <a:spLocks noGrp="1"/>
           </p:cNvSpPr>
@@ -2315,7 +2370,7 @@
       </p:grpSpPr>
       <p:sp>
         <p:nvSpPr>
-          <p:cNvPr id="185998639" name="Title 1"/>
+          <p:cNvPr id="161380023" name="Title 1"/>
           <p:cNvSpPr>
             <a:spLocks noGrp="1"/>
           </p:cNvSpPr>
@@ -2350,7 +2405,7 @@
       </p:sp>
       <p:sp>
         <p:nvSpPr>
-          <p:cNvPr id="2143077374" name="Text Placeholder 2"/>
+          <p:cNvPr id="723542720" name="Text Placeholder 2"/>
           <p:cNvSpPr>
             <a:spLocks noGrp="1"/>
           </p:cNvSpPr>
@@ -2472,7 +2527,7 @@
       </p:sp>
       <p:sp>
         <p:nvSpPr>
-          <p:cNvPr id="450610154" name="Date Placeholder 3"/>
+          <p:cNvPr id="184626450" name="Date Placeholder 3"/>
           <p:cNvSpPr>
             <a:spLocks noGrp="1"/>
           </p:cNvSpPr>
@@ -2498,7 +2553,7 @@
       </p:sp>
       <p:sp>
         <p:nvSpPr>
-          <p:cNvPr id="105548529" name="Footer Placeholder 4"/>
+          <p:cNvPr id="314111980" name="Footer Placeholder 4"/>
           <p:cNvSpPr>
             <a:spLocks noGrp="1"/>
           </p:cNvSpPr>
@@ -2520,7 +2575,7 @@
       </p:sp>
       <p:sp>
         <p:nvSpPr>
-          <p:cNvPr id="1773715811" name="Slide Number Placeholder 5"/>
+          <p:cNvPr id="2126647846" name="Slide Number Placeholder 5"/>
           <p:cNvSpPr>
             <a:spLocks noGrp="1"/>
           </p:cNvSpPr>
@@ -2571,7 +2626,7 @@
       </p:grpSpPr>
       <p:sp>
         <p:nvSpPr>
-          <p:cNvPr id="787311887" name="Title 1"/>
+          <p:cNvPr id="552432369" name="Title 1"/>
           <p:cNvSpPr>
             <a:spLocks noGrp="1"/>
           </p:cNvSpPr>
@@ -2597,7 +2652,7 @@
       </p:sp>
       <p:sp>
         <p:nvSpPr>
-          <p:cNvPr id="1272310980" name="Content Placeholder 2"/>
+          <p:cNvPr id="384839574" name="Content Placeholder 2"/>
           <p:cNvSpPr>
             <a:spLocks noGrp="1"/>
           </p:cNvSpPr>
@@ -2696,7 +2751,7 @@
       </p:sp>
       <p:sp>
         <p:nvSpPr>
-          <p:cNvPr id="1319523733" name="Content Placeholder 3"/>
+          <p:cNvPr id="344227256" name="Content Placeholder 3"/>
           <p:cNvSpPr>
             <a:spLocks noGrp="1"/>
           </p:cNvSpPr>
@@ -2795,7 +2850,7 @@
       </p:sp>
       <p:sp>
         <p:nvSpPr>
-          <p:cNvPr id="1447845524" name="Date Placeholder 4"/>
+          <p:cNvPr id="529373032" name="Date Placeholder 4"/>
           <p:cNvSpPr>
             <a:spLocks noGrp="1"/>
           </p:cNvSpPr>
@@ -2821,7 +2876,7 @@
       </p:sp>
       <p:sp>
         <p:nvSpPr>
-          <p:cNvPr id="1678955146" name="Footer Placeholder 5"/>
+          <p:cNvPr id="1116611203" name="Footer Placeholder 5"/>
           <p:cNvSpPr>
             <a:spLocks noGrp="1"/>
           </p:cNvSpPr>
@@ -2843,7 +2898,7 @@
       </p:sp>
       <p:sp>
         <p:nvSpPr>
-          <p:cNvPr id="995280499" name="Slide Number Placeholder 6"/>
+          <p:cNvPr id="974672030" name="Slide Number Placeholder 6"/>
           <p:cNvSpPr>
             <a:spLocks noGrp="1"/>
           </p:cNvSpPr>
@@ -2894,7 +2949,7 @@
       </p:grpSpPr>
       <p:sp>
         <p:nvSpPr>
-          <p:cNvPr id="456203848" name="Title 1"/>
+          <p:cNvPr id="896833092" name="Title 1"/>
           <p:cNvSpPr>
             <a:spLocks noGrp="1"/>
           </p:cNvSpPr>
@@ -2924,7 +2979,7 @@
       </p:sp>
       <p:sp>
         <p:nvSpPr>
-          <p:cNvPr id="1062080660" name="Text Placeholder 2"/>
+          <p:cNvPr id="501564088" name="Text Placeholder 2"/>
           <p:cNvSpPr>
             <a:spLocks noGrp="1"/>
           </p:cNvSpPr>
@@ -2992,7 +3047,7 @@
       </p:sp>
       <p:sp>
         <p:nvSpPr>
-          <p:cNvPr id="1121130014" name="Content Placeholder 3"/>
+          <p:cNvPr id="1939782618" name="Content Placeholder 3"/>
           <p:cNvSpPr>
             <a:spLocks noGrp="1"/>
           </p:cNvSpPr>
@@ -3091,7 +3146,7 @@
       </p:sp>
       <p:sp>
         <p:nvSpPr>
-          <p:cNvPr id="670511913" name="Text Placeholder 4"/>
+          <p:cNvPr id="2107623018" name="Text Placeholder 4"/>
           <p:cNvSpPr>
             <a:spLocks noGrp="1"/>
           </p:cNvSpPr>
@@ -3159,7 +3214,7 @@
       </p:sp>
       <p:sp>
         <p:nvSpPr>
-          <p:cNvPr id="330123719" name="Content Placeholder 5"/>
+          <p:cNvPr id="1469412888" name="Content Placeholder 5"/>
           <p:cNvSpPr>
             <a:spLocks noGrp="1"/>
           </p:cNvSpPr>
@@ -3258,7 +3313,7 @@
       </p:sp>
       <p:sp>
         <p:nvSpPr>
-          <p:cNvPr id="375347888" name="Date Placeholder 6"/>
+          <p:cNvPr id="688359520" name="Date Placeholder 6"/>
           <p:cNvSpPr>
             <a:spLocks noGrp="1"/>
           </p:cNvSpPr>
@@ -3284,7 +3339,7 @@
       </p:sp>
       <p:sp>
         <p:nvSpPr>
-          <p:cNvPr id="261136917" name="Footer Placeholder 7"/>
+          <p:cNvPr id="1494447321" name="Footer Placeholder 7"/>
           <p:cNvSpPr>
             <a:spLocks noGrp="1"/>
           </p:cNvSpPr>
@@ -3306,7 +3361,7 @@
       </p:sp>
       <p:sp>
         <p:nvSpPr>
-          <p:cNvPr id="424031853" name="Slide Number Placeholder 8"/>
+          <p:cNvPr id="690748511" name="Slide Number Placeholder 8"/>
           <p:cNvSpPr>
             <a:spLocks noGrp="1"/>
           </p:cNvSpPr>
@@ -3357,7 +3412,7 @@
       </p:grpSpPr>
       <p:sp>
         <p:nvSpPr>
-          <p:cNvPr id="1668697693" name="Title 1"/>
+          <p:cNvPr id="620515582" name="Title 1"/>
           <p:cNvSpPr>
             <a:spLocks noGrp="1"/>
           </p:cNvSpPr>
@@ -3383,7 +3438,7 @@
       </p:sp>
       <p:sp>
         <p:nvSpPr>
-          <p:cNvPr id="1769230266" name="Date Placeholder 2"/>
+          <p:cNvPr id="899686207" name="Date Placeholder 2"/>
           <p:cNvSpPr>
             <a:spLocks noGrp="1"/>
           </p:cNvSpPr>
@@ -3409,7 +3464,7 @@
       </p:sp>
       <p:sp>
         <p:nvSpPr>
-          <p:cNvPr id="189254275" name="Footer Placeholder 3"/>
+          <p:cNvPr id="2098904443" name="Footer Placeholder 3"/>
           <p:cNvSpPr>
             <a:spLocks noGrp="1"/>
           </p:cNvSpPr>
@@ -3431,7 +3486,7 @@
       </p:sp>
       <p:sp>
         <p:nvSpPr>
-          <p:cNvPr id="2073443033" name="Slide Number Placeholder 4"/>
+          <p:cNvPr id="1394012110" name="Slide Number Placeholder 4"/>
           <p:cNvSpPr>
             <a:spLocks noGrp="1"/>
           </p:cNvSpPr>
@@ -3482,7 +3537,7 @@
       </p:grpSpPr>
       <p:sp>
         <p:nvSpPr>
-          <p:cNvPr id="1995767210" name="Date Placeholder 1"/>
+          <p:cNvPr id="533888403" name="Date Placeholder 1"/>
           <p:cNvSpPr>
             <a:spLocks noGrp="1"/>
           </p:cNvSpPr>
@@ -3508,7 +3563,7 @@
       </p:sp>
       <p:sp>
         <p:nvSpPr>
-          <p:cNvPr id="13012706" name="Footer Placeholder 2"/>
+          <p:cNvPr id="2081217882" name="Footer Placeholder 2"/>
           <p:cNvSpPr>
             <a:spLocks noGrp="1"/>
           </p:cNvSpPr>
@@ -3530,7 +3585,7 @@
       </p:sp>
       <p:sp>
         <p:nvSpPr>
-          <p:cNvPr id="463237235" name="Slide Number Placeholder 3"/>
+          <p:cNvPr id="486296131" name="Slide Number Placeholder 3"/>
           <p:cNvSpPr>
             <a:spLocks noGrp="1"/>
           </p:cNvSpPr>
@@ -3581,7 +3636,7 @@
       </p:grpSpPr>
       <p:sp>
         <p:nvSpPr>
-          <p:cNvPr id="1207021615" name="Title 1"/>
+          <p:cNvPr id="1408413543" name="Title 1"/>
           <p:cNvSpPr>
             <a:spLocks noGrp="1"/>
           </p:cNvSpPr>
@@ -3616,7 +3671,7 @@
       </p:sp>
       <p:sp>
         <p:nvSpPr>
-          <p:cNvPr id="436707147" name="Content Placeholder 2"/>
+          <p:cNvPr id="1138940290" name="Content Placeholder 2"/>
           <p:cNvSpPr>
             <a:spLocks noGrp="1"/>
           </p:cNvSpPr>
@@ -3715,7 +3770,7 @@
       </p:sp>
       <p:sp>
         <p:nvSpPr>
-          <p:cNvPr id="690476883" name="Text Placeholder 3"/>
+          <p:cNvPr id="1074275856" name="Text Placeholder 3"/>
           <p:cNvSpPr>
             <a:spLocks noGrp="1"/>
           </p:cNvSpPr>
@@ -3783,7 +3838,7 @@
       </p:sp>
       <p:sp>
         <p:nvSpPr>
-          <p:cNvPr id="1023157590" name="Date Placeholder 4"/>
+          <p:cNvPr id="321281127" name="Date Placeholder 4"/>
           <p:cNvSpPr>
             <a:spLocks noGrp="1"/>
           </p:cNvSpPr>
@@ -3809,7 +3864,7 @@
       </p:sp>
       <p:sp>
         <p:nvSpPr>
-          <p:cNvPr id="1616068933" name="Footer Placeholder 5"/>
+          <p:cNvPr id="406050005" name="Footer Placeholder 5"/>
           <p:cNvSpPr>
             <a:spLocks noGrp="1"/>
           </p:cNvSpPr>
@@ -3831,7 +3886,7 @@
       </p:sp>
       <p:sp>
         <p:nvSpPr>
-          <p:cNvPr id="437260903" name="Slide Number Placeholder 6"/>
+          <p:cNvPr id="318804625" name="Slide Number Placeholder 6"/>
           <p:cNvSpPr>
             <a:spLocks noGrp="1"/>
           </p:cNvSpPr>
@@ -3882,7 +3937,7 @@
       </p:grpSpPr>
       <p:sp>
         <p:nvSpPr>
-          <p:cNvPr id="1325316475" name="Title 1"/>
+          <p:cNvPr id="2065268969" name="Title 1"/>
           <p:cNvSpPr>
             <a:spLocks noGrp="1"/>
           </p:cNvSpPr>
@@ -3917,7 +3972,7 @@
       </p:sp>
       <p:sp>
         <p:nvSpPr>
-          <p:cNvPr id="3911736" name="Picture Placeholder 2"/>
+          <p:cNvPr id="1731788451" name="Picture Placeholder 2"/>
           <p:cNvSpPr>
             <a:spLocks noGrp="1"/>
           </p:cNvSpPr>
@@ -3981,7 +4036,7 @@
       </p:sp>
       <p:sp>
         <p:nvSpPr>
-          <p:cNvPr id="1060392815" name="Text Placeholder 3"/>
+          <p:cNvPr id="1296812634" name="Text Placeholder 3"/>
           <p:cNvSpPr>
             <a:spLocks noGrp="1"/>
           </p:cNvSpPr>
@@ -4049,7 +4104,7 @@
       </p:sp>
       <p:sp>
         <p:nvSpPr>
-          <p:cNvPr id="223026736" name="Date Placeholder 4"/>
+          <p:cNvPr id="2074641824" name="Date Placeholder 4"/>
           <p:cNvSpPr>
             <a:spLocks noGrp="1"/>
           </p:cNvSpPr>
@@ -4075,7 +4130,7 @@
       </p:sp>
       <p:sp>
         <p:nvSpPr>
-          <p:cNvPr id="1113971939" name="Footer Placeholder 5"/>
+          <p:cNvPr id="1491121876" name="Footer Placeholder 5"/>
           <p:cNvSpPr>
             <a:spLocks noGrp="1"/>
           </p:cNvSpPr>
@@ -4097,7 +4152,7 @@
       </p:sp>
       <p:sp>
         <p:nvSpPr>
-          <p:cNvPr id="1268298373" name="Slide Number Placeholder 6"/>
+          <p:cNvPr id="1953302003" name="Slide Number Placeholder 6"/>
           <p:cNvSpPr>
             <a:spLocks noGrp="1"/>
           </p:cNvSpPr>
@@ -4153,7 +4208,7 @@
       </p:grpSpPr>
       <p:sp>
         <p:nvSpPr>
-          <p:cNvPr id="1906967735" name="Title Placeholder 1"/>
+          <p:cNvPr id="295446450" name="Title Placeholder 1"/>
           <p:cNvSpPr>
             <a:spLocks noGrp="1"/>
           </p:cNvSpPr>
@@ -4189,7 +4244,7 @@
       </p:sp>
       <p:sp>
         <p:nvSpPr>
-          <p:cNvPr id="780180953" name="Text Placeholder 2"/>
+          <p:cNvPr id="1617068687" name="Text Placeholder 2"/>
           <p:cNvSpPr>
             <a:spLocks noGrp="1"/>
           </p:cNvSpPr>
@@ -4265,7 +4320,7 @@
       </p:sp>
       <p:sp>
         <p:nvSpPr>
-          <p:cNvPr id="690931256" name="Date Placeholder 3"/>
+          <p:cNvPr id="198832603" name="Date Placeholder 3"/>
           <p:cNvSpPr>
             <a:spLocks noGrp="1"/>
           </p:cNvSpPr>
@@ -4309,7 +4364,7 @@
       </p:sp>
       <p:sp>
         <p:nvSpPr>
-          <p:cNvPr id="1394809079" name="Footer Placeholder 4"/>
+          <p:cNvPr id="1551649347" name="Footer Placeholder 4"/>
           <p:cNvSpPr>
             <a:spLocks noGrp="1"/>
           </p:cNvSpPr>
@@ -4349,7 +4404,7 @@
       </p:sp>
       <p:sp>
         <p:nvSpPr>
-          <p:cNvPr id="1031947666" name="Slide Number Placeholder 5"/>
+          <p:cNvPr id="533080719" name="Slide Number Placeholder 5"/>
           <p:cNvSpPr>
             <a:spLocks noGrp="1"/>
           </p:cNvSpPr>
@@ -4679,7 +4734,7 @@
       </p:grpSpPr>
       <p:sp>
         <p:nvSpPr>
-          <p:cNvPr id="639194588" name="Rectangle 1"/>
+          <p:cNvPr id="1786799726" name="Rectangle 1"/>
           <p:cNvSpPr/>
           <p:nvPr/>
         </p:nvSpPr>
@@ -4727,7 +4782,7 @@
       </p:sp>
       <p:sp>
         <p:nvSpPr>
-          <p:cNvPr id="277317246" name="TextBox 2"/>
+          <p:cNvPr id="308918363" name="TextBox 2"/>
           <p:cNvSpPr txBox="1"/>
           <p:nvPr/>
         </p:nvSpPr>
@@ -4765,7 +4820,7 @@
       </p:sp>
       <p:sp>
         <p:nvSpPr>
-          <p:cNvPr id="588741941" name="TextBox 3"/>
+          <p:cNvPr id="1515909949" name="TextBox 3"/>
           <p:cNvSpPr txBox="1"/>
           <p:nvPr/>
         </p:nvSpPr>
@@ -4803,7 +4858,7 @@
       </p:sp>
       <p:sp>
         <p:nvSpPr>
-          <p:cNvPr id="1868029059" name="TextBox 4"/>
+          <p:cNvPr id="63316599" name="TextBox 4"/>
           <p:cNvSpPr txBox="1"/>
           <p:nvPr/>
         </p:nvSpPr>
@@ -4841,7 +4896,7 @@
       </p:sp>
       <p:sp>
         <p:nvSpPr>
-          <p:cNvPr id="1184582969" name="TextBox 5"/>
+          <p:cNvPr id="1782868576" name="TextBox 5"/>
           <p:cNvSpPr txBox="1"/>
           <p:nvPr/>
         </p:nvSpPr>
@@ -4912,7 +4967,7 @@
       </p:grpSpPr>
       <p:sp>
         <p:nvSpPr>
-          <p:cNvPr id="1809230636" name="Rectangle 1"/>
+          <p:cNvPr id="66994020" name="Rectangle 1"/>
           <p:cNvSpPr/>
           <p:nvPr/>
         </p:nvSpPr>
@@ -4960,7 +5015,7 @@
       </p:sp>
       <p:sp>
         <p:nvSpPr>
-          <p:cNvPr id="2047876981" name="TextBox 2"/>
+          <p:cNvPr id="647363450" name="TextBox 2"/>
           <p:cNvSpPr txBox="1"/>
           <p:nvPr/>
         </p:nvSpPr>
@@ -4998,7 +5053,7 @@
       </p:sp>
       <p:sp>
         <p:nvSpPr>
-          <p:cNvPr id="1228335681" name="Rectangle 3"/>
+          <p:cNvPr id="1591747935" name="Rectangle 3"/>
           <p:cNvSpPr/>
           <p:nvPr/>
         </p:nvSpPr>
@@ -5046,7 +5101,7 @@
       </p:sp>
       <p:sp>
         <p:nvSpPr>
-          <p:cNvPr id="1495359675" name="TextBox 4"/>
+          <p:cNvPr id="1804441039" name="TextBox 4"/>
           <p:cNvSpPr txBox="1"/>
           <p:nvPr/>
         </p:nvSpPr>
@@ -5084,7 +5139,7 @@
       </p:sp>
       <p:pic>
         <p:nvPicPr>
-          <p:cNvPr id="252987920" name="Picture 5" descr="9.png"/>
+          <p:cNvPr id="1567749046" name="Picture 5" descr="9.png"/>
           <p:cNvPicPr>
             <a:picLocks noChangeAspect="1"/>
           </p:cNvPicPr>
@@ -5139,7 +5194,7 @@
       </p:grpSpPr>
       <p:sp>
         <p:nvSpPr>
-          <p:cNvPr id="1836311748" name="Rectangle 1"/>
+          <p:cNvPr id="2143027483" name="Rectangle 1"/>
           <p:cNvSpPr/>
           <p:nvPr/>
         </p:nvSpPr>
@@ -5187,7 +5242,7 @@
       </p:sp>
       <p:sp>
         <p:nvSpPr>
-          <p:cNvPr id="1601875332" name="TextBox 2"/>
+          <p:cNvPr id="300966198" name="TextBox 2"/>
           <p:cNvSpPr txBox="1"/>
           <p:nvPr/>
         </p:nvSpPr>
@@ -5225,7 +5280,7 @@
       </p:sp>
       <p:sp>
         <p:nvSpPr>
-          <p:cNvPr id="450914946" name="Rectangle 3"/>
+          <p:cNvPr id="502424627" name="Rectangle 3"/>
           <p:cNvSpPr/>
           <p:nvPr/>
         </p:nvSpPr>
@@ -5273,7 +5328,7 @@
       </p:sp>
       <p:sp>
         <p:nvSpPr>
-          <p:cNvPr id="1517328810" name="TextBox 4"/>
+          <p:cNvPr id="1945274036" name="TextBox 4"/>
           <p:cNvSpPr txBox="1"/>
           <p:nvPr/>
         </p:nvSpPr>
@@ -5311,7 +5366,7 @@
       </p:sp>
       <p:pic>
         <p:nvPicPr>
-          <p:cNvPr id="1269593275" name="Picture 5" descr="10.jpg"/>
+          <p:cNvPr id="305141445" name="Picture 5" descr="10.jpg"/>
           <p:cNvPicPr>
             <a:picLocks noChangeAspect="1"/>
           </p:cNvPicPr>
@@ -5366,7 +5421,7 @@
       </p:grpSpPr>
       <p:sp>
         <p:nvSpPr>
-          <p:cNvPr id="620113911" name="Rectangle 1"/>
+          <p:cNvPr id="1391465437" name="Rectangle 1"/>
           <p:cNvSpPr/>
           <p:nvPr/>
         </p:nvSpPr>
@@ -5414,7 +5469,7 @@
       </p:sp>
       <p:sp>
         <p:nvSpPr>
-          <p:cNvPr id="746118642" name="TextBox 2"/>
+          <p:cNvPr id="1835112976" name="TextBox 2"/>
           <p:cNvSpPr txBox="1"/>
           <p:nvPr/>
         </p:nvSpPr>
@@ -5452,7 +5507,7 @@
       </p:sp>
       <p:sp>
         <p:nvSpPr>
-          <p:cNvPr id="1299681644" name="Rectangle 3"/>
+          <p:cNvPr id="897763770" name="Rectangle 3"/>
           <p:cNvSpPr/>
           <p:nvPr/>
         </p:nvSpPr>
@@ -5500,7 +5555,7 @@
       </p:sp>
       <p:sp>
         <p:nvSpPr>
-          <p:cNvPr id="1759020931" name="TextBox 4"/>
+          <p:cNvPr id="619552568" name="TextBox 4"/>
           <p:cNvSpPr txBox="1"/>
           <p:nvPr/>
         </p:nvSpPr>
@@ -5538,7 +5593,7 @@
       </p:sp>
       <p:pic>
         <p:nvPicPr>
-          <p:cNvPr id="840332984" name="Picture 5" descr="11.jpg"/>
+          <p:cNvPr id="1692839740" name="Picture 5" descr="11.jpg"/>
           <p:cNvPicPr>
             <a:picLocks noChangeAspect="1"/>
           </p:cNvPicPr>
@@ -5593,7 +5648,7 @@
       </p:grpSpPr>
       <p:sp>
         <p:nvSpPr>
-          <p:cNvPr id="1451927109" name="Rectangle 1"/>
+          <p:cNvPr id="1878868179" name="Rectangle 1"/>
           <p:cNvSpPr/>
           <p:nvPr/>
         </p:nvSpPr>
@@ -5641,7 +5696,7 @@
       </p:sp>
       <p:sp>
         <p:nvSpPr>
-          <p:cNvPr id="1614184321" name="TextBox 2"/>
+          <p:cNvPr id="65136388" name="TextBox 2"/>
           <p:cNvSpPr txBox="1"/>
           <p:nvPr/>
         </p:nvSpPr>
@@ -5679,7 +5734,7 @@
       </p:sp>
       <p:sp>
         <p:nvSpPr>
-          <p:cNvPr id="1774839312" name="Rectangle 3"/>
+          <p:cNvPr id="532739314" name="Rectangle 3"/>
           <p:cNvSpPr/>
           <p:nvPr/>
         </p:nvSpPr>
@@ -5727,7 +5782,7 @@
       </p:sp>
       <p:sp>
         <p:nvSpPr>
-          <p:cNvPr id="1481602776" name="TextBox 4"/>
+          <p:cNvPr id="562080876" name="TextBox 4"/>
           <p:cNvSpPr txBox="1"/>
           <p:nvPr/>
         </p:nvSpPr>
@@ -5765,7 +5820,7 @@
       </p:sp>
       <p:pic>
         <p:nvPicPr>
-          <p:cNvPr id="259003694" name="Picture 5" descr="2.jpg"/>
+          <p:cNvPr id="1755872369" name="Picture 5" descr="2.jpg"/>
           <p:cNvPicPr>
             <a:picLocks noChangeAspect="1"/>
           </p:cNvPicPr>
@@ -5820,7 +5875,7 @@
       </p:grpSpPr>
       <p:sp>
         <p:nvSpPr>
-          <p:cNvPr id="755984138" name="Rectangle 1"/>
+          <p:cNvPr id="86311124" name="Rectangle 1"/>
           <p:cNvSpPr/>
           <p:nvPr/>
         </p:nvSpPr>
@@ -5868,7 +5923,7 @@
       </p:sp>
       <p:sp>
         <p:nvSpPr>
-          <p:cNvPr id="970236946" name="TextBox 2"/>
+          <p:cNvPr id="1047033023" name="TextBox 2"/>
           <p:cNvSpPr txBox="1"/>
           <p:nvPr/>
         </p:nvSpPr>
@@ -5906,7 +5961,7 @@
       </p:sp>
       <p:sp>
         <p:nvSpPr>
-          <p:cNvPr id="1989418278" name="Rectangle 3"/>
+          <p:cNvPr id="1845571256" name="Rectangle 3"/>
           <p:cNvSpPr/>
           <p:nvPr/>
         </p:nvSpPr>
@@ -5954,7 +6009,7 @@
       </p:sp>
       <p:sp>
         <p:nvSpPr>
-          <p:cNvPr id="1129942702" name="TextBox 4"/>
+          <p:cNvPr id="59661548" name="TextBox 4"/>
           <p:cNvSpPr txBox="1"/>
           <p:nvPr/>
         </p:nvSpPr>
@@ -5992,7 +6047,7 @@
       </p:sp>
       <p:pic>
         <p:nvPicPr>
-          <p:cNvPr id="1479197994" name="Picture 5" descr="3.jpg"/>
+          <p:cNvPr id="2037370453" name="Picture 5" descr="3.jpg"/>
           <p:cNvPicPr>
             <a:picLocks noChangeAspect="1"/>
           </p:cNvPicPr>
@@ -6047,7 +6102,7 @@
       </p:grpSpPr>
       <p:sp>
         <p:nvSpPr>
-          <p:cNvPr id="231065065" name="Rectangle 1"/>
+          <p:cNvPr id="1007645595" name="Rectangle 1"/>
           <p:cNvSpPr/>
           <p:nvPr/>
         </p:nvSpPr>
@@ -6095,7 +6150,7 @@
       </p:sp>
       <p:sp>
         <p:nvSpPr>
-          <p:cNvPr id="932308694" name="TextBox 2"/>
+          <p:cNvPr id="859844562" name="TextBox 2"/>
           <p:cNvSpPr txBox="1"/>
           <p:nvPr/>
         </p:nvSpPr>
@@ -6133,7 +6188,7 @@
       </p:sp>
       <p:sp>
         <p:nvSpPr>
-          <p:cNvPr id="77408131" name="Rectangle 3"/>
+          <p:cNvPr id="497637172" name="Rectangle 3"/>
           <p:cNvSpPr/>
           <p:nvPr/>
         </p:nvSpPr>
@@ -6181,7 +6236,7 @@
       </p:sp>
       <p:sp>
         <p:nvSpPr>
-          <p:cNvPr id="1775924712" name="TextBox 4"/>
+          <p:cNvPr id="1796014228" name="TextBox 4"/>
           <p:cNvSpPr txBox="1"/>
           <p:nvPr/>
         </p:nvSpPr>
@@ -6219,7 +6274,7 @@
       </p:sp>
       <p:pic>
         <p:nvPicPr>
-          <p:cNvPr id="1697694807" name=""/>
+          <p:cNvPr id="448576303" name=""/>
           <p:cNvPicPr>
             <a:picLocks noChangeAspect="1"/>
           </p:cNvPicPr>
@@ -6275,7 +6330,7 @@
       </p:grpSpPr>
       <p:sp>
         <p:nvSpPr>
-          <p:cNvPr id="729873326" name="Rectangle 1"/>
+          <p:cNvPr id="1315945376" name="Rectangle 1"/>
           <p:cNvSpPr/>
           <p:nvPr/>
         </p:nvSpPr>
@@ -6323,7 +6378,7 @@
       </p:sp>
       <p:sp>
         <p:nvSpPr>
-          <p:cNvPr id="68549904" name="TextBox 2"/>
+          <p:cNvPr id="1015367162" name="TextBox 2"/>
           <p:cNvSpPr txBox="1"/>
           <p:nvPr/>
         </p:nvSpPr>
@@ -6361,7 +6416,7 @@
       </p:sp>
       <p:sp>
         <p:nvSpPr>
-          <p:cNvPr id="963460569" name="Rectangle 3"/>
+          <p:cNvPr id="1624952244" name="Rectangle 3"/>
           <p:cNvSpPr/>
           <p:nvPr/>
         </p:nvSpPr>
@@ -6409,7 +6464,7 @@
       </p:sp>
       <p:sp>
         <p:nvSpPr>
-          <p:cNvPr id="1796451335" name="TextBox 4"/>
+          <p:cNvPr id="297613882" name="TextBox 4"/>
           <p:cNvSpPr txBox="1"/>
           <p:nvPr/>
         </p:nvSpPr>
@@ -6447,7 +6502,7 @@
       </p:sp>
       <p:pic>
         <p:nvPicPr>
-          <p:cNvPr id="29224576" name="Picture 5" descr="4.jpg"/>
+          <p:cNvPr id="1860362981" name="Picture 5" descr="4.jpg"/>
           <p:cNvPicPr>
             <a:picLocks noChangeAspect="1"/>
           </p:cNvPicPr>
@@ -6502,7 +6557,7 @@
       </p:grpSpPr>
       <p:sp>
         <p:nvSpPr>
-          <p:cNvPr id="498192671" name="Rectangle 1"/>
+          <p:cNvPr id="1226658640" name="Rectangle 1"/>
           <p:cNvSpPr/>
           <p:nvPr/>
         </p:nvSpPr>
@@ -6550,7 +6605,7 @@
       </p:sp>
       <p:sp>
         <p:nvSpPr>
-          <p:cNvPr id="1398655533" name="TextBox 2"/>
+          <p:cNvPr id="213446051" name="TextBox 2"/>
           <p:cNvSpPr txBox="1"/>
           <p:nvPr/>
         </p:nvSpPr>
@@ -6588,7 +6643,7 @@
       </p:sp>
       <p:sp>
         <p:nvSpPr>
-          <p:cNvPr id="586589345" name="Rectangle 3"/>
+          <p:cNvPr id="2121470731" name="Rectangle 3"/>
           <p:cNvSpPr/>
           <p:nvPr/>
         </p:nvSpPr>
@@ -6636,7 +6691,7 @@
       </p:sp>
       <p:sp>
         <p:nvSpPr>
-          <p:cNvPr id="214270243" name="TextBox 4"/>
+          <p:cNvPr id="908992610" name="TextBox 4"/>
           <p:cNvSpPr txBox="1"/>
           <p:nvPr/>
         </p:nvSpPr>
@@ -6674,7 +6729,7 @@
       </p:sp>
       <p:pic>
         <p:nvPicPr>
-          <p:cNvPr id="1664327784" name=""/>
+          <p:cNvPr id="416440748" name=""/>
           <p:cNvPicPr>
             <a:picLocks noChangeAspect="1"/>
           </p:cNvPicPr>
@@ -6730,7 +6785,7 @@
       </p:grpSpPr>
       <p:sp>
         <p:nvSpPr>
-          <p:cNvPr id="1593140685" name="Rectangle 1"/>
+          <p:cNvPr id="1054673285" name="Rectangle 1"/>
           <p:cNvSpPr/>
           <p:nvPr/>
         </p:nvSpPr>
@@ -6778,7 +6833,7 @@
       </p:sp>
       <p:sp>
         <p:nvSpPr>
-          <p:cNvPr id="2078733264" name="TextBox 2"/>
+          <p:cNvPr id="509341273" name="TextBox 2"/>
           <p:cNvSpPr txBox="1"/>
           <p:nvPr/>
         </p:nvSpPr>
@@ -6816,7 +6871,7 @@
       </p:sp>
       <p:sp>
         <p:nvSpPr>
-          <p:cNvPr id="755349241" name="Rectangle 3"/>
+          <p:cNvPr id="2062191814" name="Rectangle 3"/>
           <p:cNvSpPr/>
           <p:nvPr/>
         </p:nvSpPr>
@@ -6864,7 +6919,7 @@
       </p:sp>
       <p:sp>
         <p:nvSpPr>
-          <p:cNvPr id="175640412" name="TextBox 4"/>
+          <p:cNvPr id="226922675" name="TextBox 4"/>
           <p:cNvSpPr txBox="1"/>
           <p:nvPr/>
         </p:nvSpPr>
@@ -6902,7 +6957,7 @@
       </p:sp>
       <p:pic>
         <p:nvPicPr>
-          <p:cNvPr id="1854104535" name="Picture 5" descr="6.jpg"/>
+          <p:cNvPr id="837137821" name="Picture 5" descr="6.jpg"/>
           <p:cNvPicPr>
             <a:picLocks noChangeAspect="1"/>
           </p:cNvPicPr>
@@ -6957,7 +7012,7 @@
       </p:grpSpPr>
       <p:sp>
         <p:nvSpPr>
-          <p:cNvPr id="1192061510" name="Rectangle 1"/>
+          <p:cNvPr id="1152163503" name="Rectangle 1"/>
           <p:cNvSpPr/>
           <p:nvPr/>
         </p:nvSpPr>
@@ -7005,7 +7060,7 @@
       </p:sp>
       <p:sp>
         <p:nvSpPr>
-          <p:cNvPr id="20600090" name="TextBox 2"/>
+          <p:cNvPr id="1636169217" name="TextBox 2"/>
           <p:cNvSpPr txBox="1"/>
           <p:nvPr/>
         </p:nvSpPr>
@@ -7043,7 +7098,7 @@
       </p:sp>
       <p:sp>
         <p:nvSpPr>
-          <p:cNvPr id="2013292275" name="Rectangle 3"/>
+          <p:cNvPr id="1788552581" name="Rectangle 3"/>
           <p:cNvSpPr/>
           <p:nvPr/>
         </p:nvSpPr>
@@ -7091,7 +7146,7 @@
       </p:sp>
       <p:sp>
         <p:nvSpPr>
-          <p:cNvPr id="323902544" name="TextBox 4"/>
+          <p:cNvPr id="372132521" name="TextBox 4"/>
           <p:cNvSpPr txBox="1"/>
           <p:nvPr/>
         </p:nvSpPr>
@@ -7129,7 +7184,7 @@
       </p:sp>
       <p:pic>
         <p:nvPicPr>
-          <p:cNvPr id="1472051836" name=""/>
+          <p:cNvPr id="1253058145" name=""/>
           <p:cNvPicPr>
             <a:picLocks noChangeAspect="1"/>
           </p:cNvPicPr>
@@ -7184,7 +7239,7 @@
       </p:grpSpPr>
       <p:sp>
         <p:nvSpPr>
-          <p:cNvPr id="1407828175" name="Rectangle 1"/>
+          <p:cNvPr id="112307846" name="Rectangle 1"/>
           <p:cNvSpPr/>
           <p:nvPr/>
         </p:nvSpPr>
@@ -7232,7 +7287,7 @@
       </p:sp>
       <p:sp>
         <p:nvSpPr>
-          <p:cNvPr id="703431102" name="TextBox 2"/>
+          <p:cNvPr id="1172846339" name="TextBox 2"/>
           <p:cNvSpPr txBox="1"/>
           <p:nvPr/>
         </p:nvSpPr>
@@ -7270,7 +7325,7 @@
       </p:sp>
       <p:sp>
         <p:nvSpPr>
-          <p:cNvPr id="2124051014" name="Rectangle 3"/>
+          <p:cNvPr id="821821123" name="Rectangle 3"/>
           <p:cNvSpPr/>
           <p:nvPr/>
         </p:nvSpPr>
@@ -7318,7 +7373,7 @@
       </p:sp>
       <p:sp>
         <p:nvSpPr>
-          <p:cNvPr id="161702596" name="TextBox 4"/>
+          <p:cNvPr id="835880321" name="TextBox 4"/>
           <p:cNvSpPr txBox="1"/>
           <p:nvPr/>
         </p:nvSpPr>
@@ -7356,7 +7411,7 @@
       </p:sp>
       <p:pic>
         <p:nvPicPr>
-          <p:cNvPr id="1479726858" name="Picture 5" descr="8.png"/>
+          <p:cNvPr id="1806266646" name="Picture 5" descr="8.png"/>
           <p:cNvPicPr>
             <a:picLocks noChangeAspect="1"/>
           </p:cNvPicPr>

</xml_diff>